<commit_message>
Number the Orchestrate steps clearly across slides 15-24
Slide titles now say Step 1-7; inner loop labels use A-D so they do
not clash with step numbers. PDF re-exported.

Co-Authored-By: Claude Sonnet 5.5 <noreply@anthropic.com>
</commit_message>
<xml_diff>
--- a/resources/claude_code_vscode_tricks.pptx
+++ b/resources/claude_code_vscode_tricks.pptx
@@ -7739,7 +7739,7 @@
                 </a:solidFill>
                 <a:latin typeface="Calibri"/>
               </a:rPr>
-              <a:t>Talk the problem: ideas, doubts, decisions</a:t>
+              <a:t>Talk it through: ideas, doubts, decisions</a:t>
             </a:r>
           </a:p>
         </p:txBody>
@@ -8107,7 +8107,7 @@
                 </a:solidFill>
                 <a:latin typeface="Calibri"/>
               </a:rPr>
-              <a:t>Iterate: build, verify, self-correct</a:t>
+              <a:t>Build, verify, self-correct (exit gates)</a:t>
             </a:r>
           </a:p>
         </p:txBody>
@@ -8587,7 +8587,7 @@
                 </a:solidFill>
                 <a:latin typeface="Calibri"/>
               </a:rPr>
-              <a:t>1</a:t>
+              <a:t>A</a:t>
             </a:r>
           </a:p>
         </p:txBody>
@@ -8745,7 +8745,7 @@
                 </a:solidFill>
                 <a:latin typeface="Calibri"/>
               </a:rPr>
-              <a:t>2</a:t>
+              <a:t>B</a:t>
             </a:r>
           </a:p>
         </p:txBody>
@@ -8903,7 +8903,7 @@
                 </a:solidFill>
                 <a:latin typeface="Calibri"/>
               </a:rPr>
-              <a:t>3</a:t>
+              <a:t>C</a:t>
             </a:r>
           </a:p>
         </p:txBody>
@@ -9061,7 +9061,7 @@
                 </a:solidFill>
                 <a:latin typeface="Calibri"/>
               </a:rPr>
-              <a:t>4</a:t>
+              <a:t>D</a:t>
             </a:r>
           </a:p>
         </p:txBody>
@@ -10554,7 +10554,7 @@
                 </a:solidFill>
                 <a:latin typeface="Calibri"/>
               </a:rPr>
-              <a:t>Start every job the same way: </a:t>
+              <a:t>Steps 1-2: </a:t>
             </a:r>
             <a:r>
               <a:rPr sz="3000" b="1" i="0">
@@ -10957,7 +10957,7 @@
                 </a:solidFill>
                 <a:latin typeface="Calibri"/>
               </a:rPr>
-              <a:t>Decisions are made out loud; the next step writes them down</a:t>
+              <a:t>Decisions are said out loud, then written down</a:t>
             </a:r>
           </a:p>
         </p:txBody>
@@ -11162,7 +11162,7 @@
                 </a:solidFill>
                 <a:latin typeface="Calibri"/>
               </a:rPr>
-              <a:t>Then say </a:t>
+              <a:t>Step 3: say </a:t>
             </a:r>
             <a:r>
               <a:rPr sz="3000" b="1" i="0">
@@ -11171,7 +11171,7 @@
                 </a:solidFill>
                 <a:latin typeface="Calibri"/>
               </a:rPr>
-              <a:t>“initialize”: docs and project, done</a:t>
+              <a:t>“initialize”: docs and project</a:t>
             </a:r>
             <a:endParaRPr lang="en-US" sz="3000" dirty="0"/>
           </a:p>
@@ -13533,7 +13533,7 @@
                 </a:solidFill>
                 <a:latin typeface="Calibri"/>
               </a:rPr>
-              <a:t>progress.md</a:t>
+              <a:t>Step 5: progress.md</a:t>
             </a:r>
             <a:r>
               <a:rPr sz="3000" b="1" i="0">
@@ -13542,7 +13542,7 @@
                 </a:solidFill>
                 <a:latin typeface="Calibri"/>
               </a:rPr>
-              <a:t>: the file that drives the whole loop</a:t>
+              <a:t> drives the whole loop</a:t>
             </a:r>
             <a:endParaRPr lang="en-US" sz="3000" dirty="0"/>
           </a:p>
@@ -14447,7 +14447,7 @@
                 </a:solidFill>
                 <a:latin typeface="Calibri"/>
               </a:rPr>
-              <a:t>Each pass: build, verify, </a:t>
+              <a:t>Step 6: build, verify, </a:t>
             </a:r>
             <a:r>
               <a:rPr sz="3000" b="1" i="0">
@@ -14598,7 +14598,7 @@
                 </a:solidFill>
                 <a:latin typeface="Calibri"/>
               </a:rPr>
-              <a:t>1  Read</a:t>
+              <a:t>A  Read</a:t>
             </a:r>
           </a:p>
         </p:txBody>
@@ -14719,7 +14719,7 @@
                 </a:solidFill>
                 <a:latin typeface="Calibri"/>
               </a:rPr>
-              <a:t>2  Do</a:t>
+              <a:t>B  Do</a:t>
             </a:r>
           </a:p>
         </p:txBody>
@@ -14840,7 +14840,7 @@
                 </a:solidFill>
                 <a:latin typeface="Calibri"/>
               </a:rPr>
-              <a:t>3  Verify</a:t>
+              <a:t>C  Verify</a:t>
             </a:r>
           </a:p>
         </p:txBody>
@@ -15475,7 +15475,7 @@
                 </a:solidFill>
                 <a:latin typeface="Calibri"/>
               </a:rPr>
-              <a:t>Exit gates</a:t>
+              <a:t>Step 6 gates</a:t>
             </a:r>
             <a:r>
               <a:rPr sz="3000" b="1" i="0">
@@ -15484,7 +15484,7 @@
                 </a:solidFill>
                 <a:latin typeface="Calibri"/>
               </a:rPr>
-              <a:t>: a short pass-or-fail check for every phase</a:t>
+              <a:t>: a pass-or-fail check per phase</a:t>
             </a:r>
             <a:endParaRPr lang="en-US" sz="3000" dirty="0"/>
           </a:p>
@@ -16359,7 +16359,7 @@
                 </a:solidFill>
                 <a:latin typeface="Calibri"/>
               </a:rPr>
-              <a:t>One phase at a time, or </a:t>
+              <a:t>Step 7: one phase at a time, or </a:t>
             </a:r>
             <a:r>
               <a:rPr sz="3000" b="1" i="0">
@@ -16368,7 +16368,7 @@
                 </a:solidFill>
                 <a:latin typeface="Calibri"/>
               </a:rPr>
-              <a:t>all phases at once</a:t>
+              <a:t>all at once</a:t>
             </a:r>
             <a:endParaRPr lang="en-US" sz="3000" dirty="0"/>
           </a:p>

</xml_diff>